<commit_message>
Session 7, 8 ,9
</commit_message>
<xml_diff>
--- a/Session5/WaytoCommunicateOPENAI/MultipleWaysTocommunicate.pptx
+++ b/Session5/WaytoCommunicateOPENAI/MultipleWaysTocommunicate.pptx
@@ -15,6 +15,9 @@
     <p:sldId id="275" r:id="rId9"/>
     <p:sldId id="276" r:id="rId10"/>
     <p:sldId id="277" r:id="rId11"/>
+    <p:sldId id="278" r:id="rId12"/>
+    <p:sldId id="279" r:id="rId13"/>
+    <p:sldId id="280" r:id="rId14"/>
   </p:sldIdLst>
   <p:sldSz cx="12192000" cy="6858000"/>
   <p:notesSz cx="6858000" cy="9144000"/>
@@ -8294,6 +8297,682 @@
 </p:sld>
 </file>
 
+<file path=ppt/slides/slide11.xml><?xml version="1.0" encoding="utf-8"?>
+<p:sld xmlns:a="http://schemas.openxmlformats.org/drawingml/2006/main" xmlns:r="http://schemas.openxmlformats.org/officeDocument/2006/relationships" xmlns:p="http://schemas.openxmlformats.org/presentationml/2006/main">
+  <p:cSld>
+    <p:spTree>
+      <p:nvGrpSpPr>
+        <p:cNvPr id="1" name=""/>
+        <p:cNvGrpSpPr/>
+        <p:nvPr/>
+      </p:nvGrpSpPr>
+      <p:grpSpPr>
+        <a:xfrm>
+          <a:off x="0" y="0"/>
+          <a:ext cx="0" cy="0"/>
+          <a:chOff x="0" y="0"/>
+          <a:chExt cx="0" cy="0"/>
+        </a:xfrm>
+      </p:grpSpPr>
+      <p:sp>
+        <p:nvSpPr>
+          <p:cNvPr id="2" name="Title 1"/>
+          <p:cNvSpPr>
+            <a:spLocks noGrp="1"/>
+          </p:cNvSpPr>
+          <p:nvPr>
+            <p:ph type="title"/>
+          </p:nvPr>
+        </p:nvSpPr>
+        <p:spPr/>
+        <p:txBody>
+          <a:bodyPr/>
+          <a:lstStyle/>
+          <a:p>
+            <a:r>
+              <a:rPr lang="en-US" dirty="0" smtClean="0"/>
+              <a:t>Chat Tool</a:t>
+            </a:r>
+            <a:endParaRPr lang="en-IN" dirty="0"/>
+          </a:p>
+        </p:txBody>
+      </p:sp>
+      <p:sp>
+        <p:nvSpPr>
+          <p:cNvPr id="7" name="Rectangle 6"/>
+          <p:cNvSpPr/>
+          <p:nvPr/>
+        </p:nvSpPr>
+        <p:spPr>
+          <a:xfrm>
+            <a:off x="1022944" y="1895594"/>
+            <a:ext cx="9446936" cy="369332"/>
+          </a:xfrm>
+          <a:prstGeom prst="rect">
+            <a:avLst/>
+          </a:prstGeom>
+        </p:spPr>
+        <p:txBody>
+          <a:bodyPr wrap="square">
+            <a:spAutoFit/>
+          </a:bodyPr>
+          <a:lstStyle/>
+          <a:p>
+            <a:r>
+              <a:rPr lang="en-US" dirty="0"/>
+              <a:t>WHAT tools the AI is allowed to </a:t>
+            </a:r>
+            <a:r>
+              <a:rPr lang="en-US" dirty="0" smtClean="0"/>
+              <a:t>use </a:t>
+            </a:r>
+            <a:endParaRPr lang="en-IN" dirty="0"/>
+          </a:p>
+        </p:txBody>
+      </p:sp>
+      <p:sp>
+        <p:nvSpPr>
+          <p:cNvPr id="10" name="Rectangle 5"/>
+          <p:cNvSpPr>
+            <a:spLocks noChangeArrowheads="1"/>
+          </p:cNvSpPr>
+          <p:nvPr/>
+        </p:nvSpPr>
+        <p:spPr bwMode="auto">
+          <a:xfrm>
+            <a:off x="502920" y="2466053"/>
+            <a:ext cx="3766480" cy="584775"/>
+          </a:xfrm>
+          <a:prstGeom prst="rect">
+            <a:avLst/>
+          </a:prstGeom>
+          <a:noFill/>
+          <a:ln>
+            <a:noFill/>
+          </a:ln>
+          <a:effectLst/>
+          <a:extLst>
+            <a:ext uri="{909E8E84-426E-40DD-AFC4-6F175D3DCCD1}">
+              <a14:hiddenFill xmlns:a14="http://schemas.microsoft.com/office/drawing/2010/main">
+                <a:solidFill>
+                  <a:schemeClr val="accent1"/>
+                </a:solidFill>
+              </a14:hiddenFill>
+            </a:ext>
+            <a:ext uri="{91240B29-F687-4F45-9708-019B960494DF}">
+              <a14:hiddenLine xmlns:a14="http://schemas.microsoft.com/office/drawing/2010/main" w="9525">
+                <a:solidFill>
+                  <a:schemeClr val="tx1"/>
+                </a:solidFill>
+                <a:miter lim="800000"/>
+                <a:headEnd/>
+                <a:tailEnd/>
+              </a14:hiddenLine>
+            </a:ext>
+            <a:ext uri="{AF507438-7753-43E0-B8FC-AC1667EBCBE1}">
+              <a14:hiddenEffects xmlns:a14="http://schemas.microsoft.com/office/drawing/2010/main">
+                <a:effectLst>
+                  <a:outerShdw dist="35921" dir="2700000" algn="ctr" rotWithShape="0">
+                    <a:schemeClr val="bg2"/>
+                  </a:outerShdw>
+                </a:effectLst>
+              </a14:hiddenEffects>
+            </a:ext>
+          </a:extLst>
+        </p:spPr>
+        <p:txBody>
+          <a:bodyPr vert="horz" wrap="none" lIns="91440" tIns="45720" rIns="91440" bIns="45720" numCol="1" anchor="ctr" anchorCtr="0" compatLnSpc="1">
+            <a:prstTxWarp prst="textNoShape">
+              <a:avLst/>
+            </a:prstTxWarp>
+            <a:spAutoFit/>
+          </a:bodyPr>
+          <a:lstStyle/>
+          <a:p>
+            <a:pPr lvl="1" eaLnBrk="0" fontAlgn="base" hangingPunct="0">
+              <a:spcBef>
+                <a:spcPct val="0"/>
+              </a:spcBef>
+              <a:spcAft>
+                <a:spcPct val="0"/>
+              </a:spcAft>
+            </a:pPr>
+            <a:r>
+              <a:rPr kumimoji="0" lang="en-US" sz="1600" i="0" u="none" strike="noStrike" cap="none" normalizeH="0" baseline="0" dirty="0" err="1" smtClean="0">
+                <a:ln>
+                  <a:noFill/>
+                </a:ln>
+                <a:solidFill>
+                  <a:schemeClr val="tx1"/>
+                </a:solidFill>
+                <a:effectLst/>
+                <a:latin typeface="Arial Unicode MS" panose="020B0604020202020204" pitchFamily="34" charset="-128"/>
+              </a:rPr>
+              <a:t>ChatTool</a:t>
+            </a:r>
+            <a:r>
+              <a:rPr kumimoji="0" lang="en-US" sz="1600" i="0" u="none" strike="noStrike" cap="none" normalizeH="0" baseline="0" dirty="0" smtClean="0">
+                <a:ln>
+                  <a:noFill/>
+                </a:ln>
+                <a:solidFill>
+                  <a:schemeClr val="tx1"/>
+                </a:solidFill>
+                <a:effectLst/>
+              </a:rPr>
+              <a:t> represents a </a:t>
+            </a:r>
+            <a:r>
+              <a:rPr kumimoji="0" lang="en-US" sz="1600" i="0" u="none" strike="noStrike" cap="none" normalizeH="0" baseline="0" dirty="0" smtClean="0">
+                <a:ln>
+                  <a:noFill/>
+                </a:ln>
+                <a:solidFill>
+                  <a:schemeClr val="tx1"/>
+                </a:solidFill>
+                <a:effectLst/>
+                <a:latin typeface="Arial" panose="020B0604020202020204" pitchFamily="34" charset="0"/>
+              </a:rPr>
+              <a:t>tool/function </a:t>
+            </a:r>
+          </a:p>
+          <a:p>
+            <a:pPr lvl="1" eaLnBrk="0" fontAlgn="base" hangingPunct="0">
+              <a:spcBef>
+                <a:spcPct val="0"/>
+              </a:spcBef>
+              <a:spcAft>
+                <a:spcPct val="0"/>
+              </a:spcAft>
+            </a:pPr>
+            <a:r>
+              <a:rPr kumimoji="0" lang="en-US" sz="1600" i="0" u="none" strike="noStrike" cap="none" normalizeH="0" baseline="0" dirty="0" smtClean="0">
+                <a:ln>
+                  <a:noFill/>
+                </a:ln>
+                <a:solidFill>
+                  <a:schemeClr val="tx1"/>
+                </a:solidFill>
+                <a:effectLst/>
+                <a:latin typeface="Arial" panose="020B0604020202020204" pitchFamily="34" charset="0"/>
+              </a:rPr>
+              <a:t>that you expose to the model. </a:t>
+            </a:r>
+          </a:p>
+        </p:txBody>
+      </p:sp>
+      <p:pic>
+        <p:nvPicPr>
+          <p:cNvPr id="13" name="Picture 12"/>
+          <p:cNvPicPr>
+            <a:picLocks noChangeAspect="1"/>
+          </p:cNvPicPr>
+          <p:nvPr/>
+        </p:nvPicPr>
+        <p:blipFill>
+          <a:blip r:embed="rId2"/>
+          <a:stretch>
+            <a:fillRect/>
+          </a:stretch>
+        </p:blipFill>
+        <p:spPr>
+          <a:xfrm>
+            <a:off x="4572000" y="1737360"/>
+            <a:ext cx="6652259" cy="4448157"/>
+          </a:xfrm>
+          <a:prstGeom prst="rect">
+            <a:avLst/>
+          </a:prstGeom>
+        </p:spPr>
+      </p:pic>
+    </p:spTree>
+    <p:extLst>
+      <p:ext uri="{BB962C8B-B14F-4D97-AF65-F5344CB8AC3E}">
+        <p14:creationId xmlns:p14="http://schemas.microsoft.com/office/powerpoint/2010/main" val="964276102"/>
+      </p:ext>
+    </p:extLst>
+  </p:cSld>
+  <p:clrMapOvr>
+    <a:masterClrMapping/>
+  </p:clrMapOvr>
+</p:sld>
+</file>
+
+<file path=ppt/slides/slide12.xml><?xml version="1.0" encoding="utf-8"?>
+<p:sld xmlns:a="http://schemas.openxmlformats.org/drawingml/2006/main" xmlns:r="http://schemas.openxmlformats.org/officeDocument/2006/relationships" xmlns:p="http://schemas.openxmlformats.org/presentationml/2006/main">
+  <p:cSld>
+    <p:spTree>
+      <p:nvGrpSpPr>
+        <p:cNvPr id="1" name=""/>
+        <p:cNvGrpSpPr/>
+        <p:nvPr/>
+      </p:nvGrpSpPr>
+      <p:grpSpPr>
+        <a:xfrm>
+          <a:off x="0" y="0"/>
+          <a:ext cx="0" cy="0"/>
+          <a:chOff x="0" y="0"/>
+          <a:chExt cx="0" cy="0"/>
+        </a:xfrm>
+      </p:grpSpPr>
+      <p:sp>
+        <p:nvSpPr>
+          <p:cNvPr id="2" name="Title 1"/>
+          <p:cNvSpPr>
+            <a:spLocks noGrp="1"/>
+          </p:cNvSpPr>
+          <p:nvPr>
+            <p:ph type="title"/>
+          </p:nvPr>
+        </p:nvSpPr>
+        <p:spPr/>
+        <p:txBody>
+          <a:bodyPr/>
+          <a:lstStyle/>
+          <a:p>
+            <a:r>
+              <a:rPr lang="en-IN" dirty="0" smtClean="0"/>
+              <a:t>Chat Tool</a:t>
+            </a:r>
+            <a:endParaRPr lang="en-IN" dirty="0"/>
+          </a:p>
+        </p:txBody>
+      </p:sp>
+      <p:sp>
+        <p:nvSpPr>
+          <p:cNvPr id="3" name="Content Placeholder 2"/>
+          <p:cNvSpPr>
+            <a:spLocks noGrp="1"/>
+          </p:cNvSpPr>
+          <p:nvPr>
+            <p:ph idx="1"/>
+          </p:nvPr>
+        </p:nvSpPr>
+        <p:spPr/>
+        <p:txBody>
+          <a:bodyPr>
+            <a:normAutofit fontScale="70000" lnSpcReduction="20000"/>
+          </a:bodyPr>
+          <a:lstStyle/>
+          <a:p>
+            <a:r>
+              <a:rPr lang="en-IN" dirty="0" err="1"/>
+              <a:t>ChatTool</a:t>
+            </a:r>
+            <a:endParaRPr lang="en-IN" dirty="0"/>
+          </a:p>
+          <a:p>
+            <a:r>
+              <a:rPr lang="en-IN" dirty="0"/>
+              <a:t>│</a:t>
+            </a:r>
+          </a:p>
+          <a:p>
+            <a:r>
+              <a:rPr lang="en-IN" dirty="0"/>
+              <a:t>├── Function Name</a:t>
+            </a:r>
+          </a:p>
+          <a:p>
+            <a:r>
+              <a:rPr lang="en-IN" dirty="0"/>
+              <a:t>│      </a:t>
+            </a:r>
+            <a:r>
+              <a:rPr lang="en-IN" dirty="0" err="1"/>
+              <a:t>getEmployeeDetails</a:t>
+            </a:r>
+            <a:endParaRPr lang="en-IN" dirty="0"/>
+          </a:p>
+          <a:p>
+            <a:r>
+              <a:rPr lang="en-IN" dirty="0"/>
+              <a:t>│</a:t>
+            </a:r>
+          </a:p>
+          <a:p>
+            <a:r>
+              <a:rPr lang="en-IN" dirty="0"/>
+              <a:t>├── Description</a:t>
+            </a:r>
+          </a:p>
+          <a:p>
+            <a:r>
+              <a:rPr lang="en-IN" dirty="0"/>
+              <a:t>│      Get employee details using employee ID</a:t>
+            </a:r>
+          </a:p>
+          <a:p>
+            <a:r>
+              <a:rPr lang="en-IN" dirty="0"/>
+              <a:t>│</a:t>
+            </a:r>
+          </a:p>
+          <a:p>
+            <a:r>
+              <a:rPr lang="en-IN" dirty="0"/>
+              <a:t>└── Parameters Schema</a:t>
+            </a:r>
+          </a:p>
+          <a:p>
+            <a:r>
+              <a:rPr lang="en-IN" dirty="0"/>
+              <a:t>       </a:t>
+            </a:r>
+            <a:r>
+              <a:rPr lang="en-IN" dirty="0" err="1"/>
+              <a:t>employeeId</a:t>
+            </a:r>
+            <a:endParaRPr lang="en-IN" dirty="0"/>
+          </a:p>
+          <a:p>
+            <a:r>
+              <a:rPr lang="en-IN" dirty="0"/>
+              <a:t>       integer</a:t>
+            </a:r>
+          </a:p>
+          <a:p>
+            <a:r>
+              <a:rPr lang="en-IN" dirty="0"/>
+              <a:t>       required</a:t>
+            </a:r>
+          </a:p>
+        </p:txBody>
+      </p:sp>
+    </p:spTree>
+    <p:extLst>
+      <p:ext uri="{BB962C8B-B14F-4D97-AF65-F5344CB8AC3E}">
+        <p14:creationId xmlns:p14="http://schemas.microsoft.com/office/powerpoint/2010/main" val="53324370"/>
+      </p:ext>
+    </p:extLst>
+  </p:cSld>
+  <p:clrMapOvr>
+    <a:masterClrMapping/>
+  </p:clrMapOvr>
+</p:sld>
+</file>
+
+<file path=ppt/slides/slide13.xml><?xml version="1.0" encoding="utf-8"?>
+<p:sld xmlns:a="http://schemas.openxmlformats.org/drawingml/2006/main" xmlns:r="http://schemas.openxmlformats.org/officeDocument/2006/relationships" xmlns:p="http://schemas.openxmlformats.org/presentationml/2006/main">
+  <p:cSld>
+    <p:spTree>
+      <p:nvGrpSpPr>
+        <p:cNvPr id="1" name=""/>
+        <p:cNvGrpSpPr/>
+        <p:nvPr/>
+      </p:nvGrpSpPr>
+      <p:grpSpPr>
+        <a:xfrm>
+          <a:off x="0" y="0"/>
+          <a:ext cx="0" cy="0"/>
+          <a:chOff x="0" y="0"/>
+          <a:chExt cx="0" cy="0"/>
+        </a:xfrm>
+      </p:grpSpPr>
+      <p:sp>
+        <p:nvSpPr>
+          <p:cNvPr id="2" name="Title 1"/>
+          <p:cNvSpPr>
+            <a:spLocks noGrp="1"/>
+          </p:cNvSpPr>
+          <p:nvPr>
+            <p:ph type="title"/>
+          </p:nvPr>
+        </p:nvSpPr>
+        <p:spPr/>
+        <p:txBody>
+          <a:bodyPr/>
+          <a:lstStyle/>
+          <a:p>
+            <a:r>
+              <a:rPr lang="en-IN" dirty="0" err="1"/>
+              <a:t>ChatCompletionOptions</a:t>
+            </a:r>
+            <a:endParaRPr lang="en-IN" dirty="0"/>
+          </a:p>
+        </p:txBody>
+      </p:sp>
+      <p:sp>
+        <p:nvSpPr>
+          <p:cNvPr id="4" name="Rectangle 1"/>
+          <p:cNvSpPr>
+            <a:spLocks noGrp="1" noChangeArrowheads="1"/>
+          </p:cNvSpPr>
+          <p:nvPr>
+            <p:ph idx="1"/>
+          </p:nvPr>
+        </p:nvSpPr>
+        <p:spPr bwMode="auto">
+          <a:xfrm>
+            <a:off x="1341120" y="1973785"/>
+            <a:ext cx="5987473" cy="307777"/>
+          </a:xfrm>
+          <a:prstGeom prst="rect">
+            <a:avLst/>
+          </a:prstGeom>
+          <a:noFill/>
+          <a:ln>
+            <a:noFill/>
+          </a:ln>
+          <a:effectLst/>
+          <a:extLst>
+            <a:ext uri="{909E8E84-426E-40DD-AFC4-6F175D3DCCD1}">
+              <a14:hiddenFill xmlns:a14="http://schemas.microsoft.com/office/drawing/2010/main">
+                <a:solidFill>
+                  <a:schemeClr val="accent1"/>
+                </a:solidFill>
+              </a14:hiddenFill>
+            </a:ext>
+            <a:ext uri="{91240B29-F687-4F45-9708-019B960494DF}">
+              <a14:hiddenLine xmlns:a14="http://schemas.microsoft.com/office/drawing/2010/main" w="9525">
+                <a:solidFill>
+                  <a:schemeClr val="tx1"/>
+                </a:solidFill>
+                <a:miter lim="800000"/>
+                <a:headEnd/>
+                <a:tailEnd/>
+              </a14:hiddenLine>
+            </a:ext>
+            <a:ext uri="{AF507438-7753-43E0-B8FC-AC1667EBCBE1}">
+              <a14:hiddenEffects xmlns:a14="http://schemas.microsoft.com/office/drawing/2010/main">
+                <a:effectLst>
+                  <a:outerShdw dist="35921" dir="2700000" algn="ctr" rotWithShape="0">
+                    <a:schemeClr val="bg2"/>
+                  </a:outerShdw>
+                </a:effectLst>
+              </a14:hiddenEffects>
+            </a:ext>
+          </a:extLst>
+        </p:spPr>
+        <p:txBody>
+          <a:bodyPr vert="horz" wrap="none" lIns="91440" tIns="45720" rIns="91440" bIns="45720" numCol="1" anchor="ctr" anchorCtr="0" compatLnSpc="1">
+            <a:prstTxWarp prst="textNoShape">
+              <a:avLst/>
+            </a:prstTxWarp>
+            <a:spAutoFit/>
+          </a:bodyPr>
+          <a:lstStyle/>
+          <a:p>
+            <a:pPr marL="0" marR="0" lvl="0" indent="0" algn="l" defTabSz="914400" rtl="0" eaLnBrk="0" fontAlgn="base" latinLnBrk="0" hangingPunct="0">
+              <a:lnSpc>
+                <a:spcPct val="100000"/>
+              </a:lnSpc>
+              <a:spcBef>
+                <a:spcPct val="0"/>
+              </a:spcBef>
+              <a:spcAft>
+                <a:spcPct val="0"/>
+              </a:spcAft>
+              <a:buClrTx/>
+              <a:buSzTx/>
+              <a:buFontTx/>
+              <a:buNone/>
+              <a:tabLst/>
+            </a:pPr>
+            <a:r>
+              <a:rPr kumimoji="0" lang="en-US" sz="1400" i="0" u="none" strike="noStrike" cap="none" normalizeH="0" baseline="0" dirty="0" err="1" smtClean="0">
+                <a:ln>
+                  <a:noFill/>
+                </a:ln>
+                <a:solidFill>
+                  <a:schemeClr val="tx1"/>
+                </a:solidFill>
+                <a:effectLst/>
+              </a:rPr>
+              <a:t>ChatCompletionOptions</a:t>
+            </a:r>
+            <a:r>
+              <a:rPr kumimoji="0" lang="en-US" sz="1400" i="0" u="none" strike="noStrike" cap="none" normalizeH="0" baseline="0" dirty="0" smtClean="0">
+                <a:ln>
+                  <a:noFill/>
+                </a:ln>
+                <a:solidFill>
+                  <a:schemeClr val="tx1"/>
+                </a:solidFill>
+                <a:effectLst/>
+              </a:rPr>
+              <a:t> contains the settings for the chat completion request. </a:t>
+            </a:r>
+          </a:p>
+        </p:txBody>
+      </p:sp>
+      <p:sp>
+        <p:nvSpPr>
+          <p:cNvPr id="5" name="Rectangle 4"/>
+          <p:cNvSpPr/>
+          <p:nvPr/>
+        </p:nvSpPr>
+        <p:spPr>
+          <a:xfrm>
+            <a:off x="1592580" y="5003159"/>
+            <a:ext cx="6096000" cy="646331"/>
+          </a:xfrm>
+          <a:prstGeom prst="rect">
+            <a:avLst/>
+          </a:prstGeom>
+        </p:spPr>
+        <p:txBody>
+          <a:bodyPr>
+            <a:spAutoFit/>
+          </a:bodyPr>
+          <a:lstStyle/>
+          <a:p>
+            <a:r>
+              <a:rPr lang="en-IN" dirty="0" err="1"/>
+              <a:t>var</a:t>
+            </a:r>
+            <a:r>
+              <a:rPr lang="en-IN" dirty="0"/>
+              <a:t> options = new </a:t>
+            </a:r>
+            <a:endParaRPr lang="en-IN" dirty="0" smtClean="0"/>
+          </a:p>
+          <a:p>
+            <a:r>
+              <a:rPr lang="en-IN" dirty="0" err="1" smtClean="0"/>
+              <a:t>ChatCompletionOptions</a:t>
+            </a:r>
+            <a:r>
+              <a:rPr lang="en-IN" dirty="0" smtClean="0"/>
+              <a:t> </a:t>
+            </a:r>
+            <a:r>
+              <a:rPr lang="en-IN" dirty="0"/>
+              <a:t>{ Temperature = 0.2f };</a:t>
+            </a:r>
+          </a:p>
+        </p:txBody>
+      </p:sp>
+      <p:sp>
+        <p:nvSpPr>
+          <p:cNvPr id="6" name="Rectangle 5"/>
+          <p:cNvSpPr/>
+          <p:nvPr/>
+        </p:nvSpPr>
+        <p:spPr>
+          <a:xfrm>
+            <a:off x="1341120" y="2349699"/>
+            <a:ext cx="6096000" cy="2585323"/>
+          </a:xfrm>
+          <a:prstGeom prst="rect">
+            <a:avLst/>
+          </a:prstGeom>
+        </p:spPr>
+        <p:txBody>
+          <a:bodyPr>
+            <a:spAutoFit/>
+          </a:bodyPr>
+          <a:lstStyle/>
+          <a:p>
+            <a:r>
+              <a:rPr lang="en-IN" dirty="0" err="1"/>
+              <a:t>ChatCompletionOptions</a:t>
+            </a:r>
+            <a:endParaRPr lang="en-IN" dirty="0"/>
+          </a:p>
+          <a:p>
+            <a:r>
+              <a:rPr lang="en-IN" dirty="0"/>
+              <a:t>        │</a:t>
+            </a:r>
+          </a:p>
+          <a:p>
+            <a:r>
+              <a:rPr lang="en-IN" dirty="0"/>
+              <a:t>        ├── Temperature</a:t>
+            </a:r>
+          </a:p>
+          <a:p>
+            <a:r>
+              <a:rPr lang="en-IN" dirty="0"/>
+              <a:t>        ├── Tools</a:t>
+            </a:r>
+          </a:p>
+          <a:p>
+            <a:r>
+              <a:rPr lang="en-IN" dirty="0"/>
+              <a:t>        ├── Max output settings</a:t>
+            </a:r>
+          </a:p>
+          <a:p>
+            <a:r>
+              <a:rPr lang="en-IN" dirty="0"/>
+              <a:t>        ├── Tool choice</a:t>
+            </a:r>
+          </a:p>
+          <a:p>
+            <a:r>
+              <a:rPr lang="en-IN" dirty="0"/>
+              <a:t>        ├── Other request options</a:t>
+            </a:r>
+          </a:p>
+          <a:p>
+            <a:r>
+              <a:rPr lang="en-IN" dirty="0"/>
+              <a:t>        │</a:t>
+            </a:r>
+          </a:p>
+          <a:p>
+            <a:r>
+              <a:rPr lang="en-IN" dirty="0"/>
+              <a:t>        └── ...</a:t>
+            </a:r>
+          </a:p>
+        </p:txBody>
+      </p:sp>
+    </p:spTree>
+    <p:extLst>
+      <p:ext uri="{BB962C8B-B14F-4D97-AF65-F5344CB8AC3E}">
+        <p14:creationId xmlns:p14="http://schemas.microsoft.com/office/powerpoint/2010/main" val="683194111"/>
+      </p:ext>
+    </p:extLst>
+  </p:cSld>
+  <p:clrMapOvr>
+    <a:masterClrMapping/>
+  </p:clrMapOvr>
+</p:sld>
+</file>
+
 <file path=ppt/slides/slide2.xml><?xml version="1.0" encoding="utf-8"?>
 <p:sld xmlns:a="http://schemas.openxmlformats.org/drawingml/2006/main" xmlns:r="http://schemas.openxmlformats.org/officeDocument/2006/relationships" xmlns:p="http://schemas.openxmlformats.org/presentationml/2006/main">
   <p:cSld>
@@ -10462,7 +11141,7 @@
         </p:blipFill>
         <p:spPr>
           <a:xfrm>
-            <a:off x="1611582" y="2001102"/>
+            <a:off x="1030468" y="2291659"/>
             <a:ext cx="7280958" cy="4095539"/>
           </a:xfrm>
           <a:prstGeom prst="rect">

</xml_diff>